<commit_message>
WaferEngine slides: add prefill memory-breakdown + op-layout slide (after decode placement)
</commit_message>
<xml_diff>
--- a/projects/WaferEngine/docs/2026-06-28/wse_per_pe_resource_analysis.pptx
+++ b/projects/WaferEngine/docs/2026-06-28/wse_per_pe_resource_analysis.pptx
@@ -10,6 +10,7 @@
     <p:sldId id="258" r:id="rId4"/>
     <p:sldId id="259" r:id="rId5"/>
     <p:sldId id="260" r:id="rId6"/>
+    <p:sldId id="266" r:id="rId15"/>
     <p:sldId id="262" r:id="rId7"/>
     <p:sldId id="263" r:id="rId8"/>
     <p:sldId id="264" r:id="rId9"/>
@@ -3185,6 +3186,288 @@
             </a:pPr>
             <a:r>
               <a:t>qwen3-1.7B on a real Cerebras WSE-3 (CS-3)  ·  memory &amp; fabric-color analysis  ·  2026-06-28</a:t>
+            </a:r>
+          </a:p>
+        </p:txBody>
+      </p:sp>
+    </p:spTree>
+  </p:cSld>
+  <p:clrMapOvr>
+    <a:masterClrMapping/>
+  </p:clrMapOvr>
+</p:sld>
+</file>
+
+<file path=ppt/slides/slide10.xml><?xml version="1.0" encoding="utf-8"?>
+<p:sld xmlns:a="http://schemas.openxmlformats.org/drawingml/2006/main" xmlns:p="http://schemas.openxmlformats.org/presentationml/2006/main" xmlns:r="http://schemas.openxmlformats.org/officeDocument/2006/relationships">
+  <p:cSld>
+    <p:spTree>
+      <p:nvGrpSpPr>
+        <p:cNvPr id="1" name=""/>
+        <p:cNvGrpSpPr/>
+        <p:nvPr/>
+      </p:nvGrpSpPr>
+      <p:grpSpPr/>
+      <p:sp>
+        <p:nvSpPr>
+          <p:cNvPr id="2" name="Rectangle 1"/>
+          <p:cNvSpPr/>
+          <p:nvPr/>
+        </p:nvSpPr>
+        <p:spPr>
+          <a:xfrm>
+            <a:off x="0" y="0"/>
+            <a:ext cx="12192000" cy="868680"/>
+          </a:xfrm>
+          <a:prstGeom prst="rect">
+            <a:avLst/>
+          </a:prstGeom>
+          <a:solidFill>
+            <a:srgbClr val="1F3A5F"/>
+          </a:solidFill>
+          <a:ln>
+            <a:noFill/>
+          </a:ln>
+        </p:spPr>
+        <p:style>
+          <a:lnRef idx="1">
+            <a:schemeClr val="accent1"/>
+          </a:lnRef>
+          <a:fillRef idx="3">
+            <a:schemeClr val="accent1"/>
+          </a:fillRef>
+          <a:effectRef idx="2">
+            <a:schemeClr val="accent1"/>
+          </a:effectRef>
+          <a:fontRef idx="minor">
+            <a:schemeClr val="lt1"/>
+          </a:fontRef>
+        </p:style>
+        <p:txBody>
+          <a:bodyPr rtlCol="0" anchor="ctr"/>
+          <a:lstStyle/>
+          <a:p>
+            <a:pPr algn="ctr"/>
+          </a:p>
+        </p:txBody>
+      </p:sp>
+      <p:sp>
+        <p:nvSpPr>
+          <p:cNvPr id="3" name="TextBox 2"/>
+          <p:cNvSpPr txBox="1"/>
+          <p:nvPr/>
+        </p:nvSpPr>
+        <p:spPr>
+          <a:xfrm>
+            <a:off x="365760" y="109728"/>
+            <a:ext cx="11430000" cy="685800"/>
+          </a:xfrm>
+          <a:prstGeom prst="rect">
+            <a:avLst/>
+          </a:prstGeom>
+          <a:noFill/>
+        </p:spPr>
+        <p:txBody>
+          <a:bodyPr wrap="square">
+            <a:spAutoFit/>
+          </a:bodyPr>
+          <a:lstStyle/>
+          <a:p>
+            <a:pPr>
+              <a:defRPr sz="2600" b="1">
+                <a:solidFill>
+                  <a:srgbClr val="FFFFFF"/>
+                </a:solidFill>
+              </a:defRPr>
+            </a:pPr>
+            <a:r>
+              <a:t>Prefill: memory breakdown + op layout</a:t>
+            </a:r>
+          </a:p>
+        </p:txBody>
+      </p:sp>
+      <p:pic>
+        <p:nvPicPr>
+          <p:cNvPr id="4" name="Picture 3" descr="prefill_stacked.png"/>
+          <p:cNvPicPr>
+            <a:picLocks noChangeAspect="1"/>
+          </p:cNvPicPr>
+          <p:nvPr/>
+        </p:nvPicPr>
+        <p:blipFill>
+          <a:blip r:embed="rId2"/>
+          <a:stretch>
+            <a:fillRect/>
+          </a:stretch>
+        </p:blipFill>
+        <p:spPr>
+          <a:xfrm>
+            <a:off x="574765" y="1051560"/>
+            <a:ext cx="5159829" cy="3611880"/>
+          </a:xfrm>
+          <a:prstGeom prst="rect">
+            <a:avLst/>
+          </a:prstGeom>
+        </p:spPr>
+      </p:pic>
+      <p:sp>
+        <p:nvSpPr>
+          <p:cNvPr id="5" name="TextBox 4"/>
+          <p:cNvSpPr txBox="1"/>
+          <p:nvPr/>
+        </p:nvSpPr>
+        <p:spPr>
+          <a:xfrm>
+            <a:off x="365760" y="4736592"/>
+            <a:ext cx="5577840" cy="365760"/>
+          </a:xfrm>
+          <a:prstGeom prst="rect">
+            <a:avLst/>
+          </a:prstGeom>
+          <a:noFill/>
+        </p:spPr>
+        <p:txBody>
+          <a:bodyPr wrap="none">
+            <a:spAutoFit/>
+          </a:bodyPr>
+          <a:lstStyle/>
+          <a:p>
+            <a:pPr algn="ctr">
+              <a:defRPr sz="1200" i="1">
+                <a:solidFill>
+                  <a:srgbClr val="555555"/>
+                </a:solidFill>
+              </a:defRPr>
+            </a:pPr>
+            <a:r>
+              <a:t>Per-role SRAM breakdown (48 KB ceiling)</a:t>
+            </a:r>
+          </a:p>
+        </p:txBody>
+      </p:sp>
+      <p:pic>
+        <p:nvPicPr>
+          <p:cNvPr id="6" name="Picture 5" descr="prefill_placement_map.png"/>
+          <p:cNvPicPr>
+            <a:picLocks noChangeAspect="1"/>
+          </p:cNvPicPr>
+          <p:nvPr/>
+        </p:nvPicPr>
+        <p:blipFill>
+          <a:blip r:embed="rId3"/>
+          <a:stretch>
+            <a:fillRect/>
+          </a:stretch>
+        </p:blipFill>
+        <p:spPr>
+          <a:xfrm>
+            <a:off x="6613310" y="1051560"/>
+            <a:ext cx="4841923" cy="3611880"/>
+          </a:xfrm>
+          <a:prstGeom prst="rect">
+            <a:avLst/>
+          </a:prstGeom>
+        </p:spPr>
+      </p:pic>
+      <p:sp>
+        <p:nvSpPr>
+          <p:cNvPr id="7" name="TextBox 6"/>
+          <p:cNvSpPr txBox="1"/>
+          <p:nvPr/>
+        </p:nvSpPr>
+        <p:spPr>
+          <a:xfrm>
+            <a:off x="6245352" y="4736592"/>
+            <a:ext cx="5577840" cy="365760"/>
+          </a:xfrm>
+          <a:prstGeom prst="rect">
+            <a:avLst/>
+          </a:prstGeom>
+          <a:noFill/>
+        </p:spPr>
+        <p:txBody>
+          <a:bodyPr wrap="none">
+            <a:spAutoFit/>
+          </a:bodyPr>
+          <a:lstStyle/>
+          <a:p>
+            <a:pPr algn="ctr">
+              <a:defRPr sz="1200" i="1">
+                <a:solidFill>
+                  <a:srgbClr val="555555"/>
+                </a:solidFill>
+              </a:defRPr>
+            </a:pPr>
+            <a:r>
+              <a:t>PE block placement: 2x2 prefill blocks + HT band</a:t>
+            </a:r>
+          </a:p>
+        </p:txBody>
+      </p:sp>
+      <p:sp>
+        <p:nvSpPr>
+          <p:cNvPr id="8" name="TextBox 7"/>
+          <p:cNvSpPr txBox="1"/>
+          <p:nvPr/>
+        </p:nvSpPr>
+        <p:spPr>
+          <a:xfrm>
+            <a:off x="457200" y="5166360"/>
+            <a:ext cx="11338560" cy="1554480"/>
+          </a:xfrm>
+          <a:prstGeom prst="rect">
+            <a:avLst/>
+          </a:prstGeom>
+          <a:noFill/>
+        </p:spPr>
+        <p:txBody>
+          <a:bodyPr wrap="square">
+            <a:spAutoFit/>
+          </a:bodyPr>
+          <a:lstStyle/>
+          <a:p>
+            <a:pPr>
+              <a:spcAft>
+                <a:spcPts val="500"/>
+              </a:spcAft>
+              <a:defRPr sz="1300">
+                <a:solidFill>
+                  <a:srgbClr val="222222"/>
+                </a:solidFill>
+              </a:defRPr>
+            </a:pPr>
+            <a:r>
+              <a:t>• Same shape as decode: ~23 KB CODE + ~11 KB weights per compute PE — but runs TIGHTER, ~82% full (~8 KB free vs decode's ~11 KB), because prefill carries the causal attention mask + larger MeshGEMM comm buffers.</a:t>
+            </a:r>
+          </a:p>
+          <a:p>
+            <a:pPr>
+              <a:spcAft>
+                <a:spcPts val="500"/>
+              </a:spcAft>
+              <a:defRPr sz="1300">
+                <a:solidFill>
+                  <a:srgbClr val="222222"/>
+                </a:solidFill>
+              </a:defRPr>
+            </a:pPr>
+            <a:r>
+              <a:t>• Op layout: ONE prefill region split into 2x2 logical blocks (vs decode's two stacked block-rows); same thin HT band — ht_head embedding (~38 KB, weight-bound) + ht_tail lm_head.</a:t>
+            </a:r>
+          </a:p>
+          <a:p>
+            <a:pPr>
+              <a:spcAft>
+                <a:spcPts val="500"/>
+              </a:spcAft>
+              <a:defRPr sz="1300">
+                <a:solidFill>
+                  <a:srgbClr val="222222"/>
+                </a:solidFill>
+              </a:defRPr>
+            </a:pPr>
+            <a:r>
+              <a:t>• Same disaggregated-memory tax: the transformer-layer code is replicated on every compute core; KV is the squeezed residual.</a:t>
             </a:r>
           </a:p>
         </p:txBody>

</xml_diff>